<commit_message>
Reframe 2026-04-28 deck as recap-of-last-talk + diff
Audience are WP4 regulars (LLM experts who know what WP4 is); ditch the
"what WP4 does" framing and instead lead with a one-slide "Last time /
Since then" recap so people can pick up from the March update without
mentally reconstructing context. Renumber slides 3-7 -> 2-6.

Co-Authored-By: Claude Opus 4.7 <noreply@anthropic.com>
</commit_message>
<xml_diff>
--- a/oellm/meetings/llms4eu_wp4/2026-04-28.pptx
+++ b/oellm/meetings/llms4eu_wp4/2026-04-28.pptx
@@ -13,7 +13,6 @@
     <p:sldId id="261" r:id="rId12"/>
     <p:sldId id="262" r:id="rId13"/>
     <p:sldId id="263" r:id="rId14"/>
-    <p:sldId id="264" r:id="rId15"/>
   </p:sldIdLst>
   <p:sldSz cx="12191695" cy="6858000" type="screen4x3"/>
   <p:notesSz cx="6858000" cy="9144000"/>
@@ -3202,7 +3201,7 @@
           <a:lstStyle/>
           <a:p>
             <a:r>
-              <a:t>Slide 1 — Context: what this work is</a:t>
+              <a:t>Slide 1 — Where we left off &amp; what's new</a:t>
             </a:r>
           </a:p>
         </p:txBody>
@@ -3225,22 +3224,7 @@
             <a:pPr/>
             <a:r>
               <a:rPr b="0" sz="1800"/>
-              <a:t>WP4 is exploring </a:t>
-            </a:r>
-            <a:r>
-              <a:rPr b="1" sz="1800"/>
-              <a:t>post-training recipes for European multilingual capability</a:t>
-            </a:r>
-            <a:r>
-              <a:rPr b="0" sz="1800"/>
-              <a:t> on top of strong open base models</a:t>
-            </a:r>
-          </a:p>
-          <a:p>
-            <a:pPr/>
-            <a:r>
-              <a:rPr b="0" sz="1800"/>
-              <a:t>Starting point: a reproduced </a:t>
+              <a:t>Reproduced </a:t>
             </a:r>
             <a:r>
               <a:rPr b="1" sz="1800"/>
@@ -3248,78 +3232,100 @@
             </a:r>
             <a:r>
               <a:rPr b="0" sz="1800"/>
-              <a:t> baseline (we re-ran AllenAI's recipe to have a controllable starting checkpoint and intermediate ckpts)</a:t>
+              <a:t> as our controllable starting checkpoint</a:t>
             </a:r>
           </a:p>
           <a:p>
             <a:pPr/>
             <a:r>
               <a:rPr b="0" sz="1800"/>
-              <a:t>Core problem: the public Dolci SFT data is </a:t>
+              <a:t>Validated with LLM-as-a-judge (Qwen3-30B-A3B) via </a:t>
             </a:r>
             <a:r>
               <a:rPr b="1" sz="1800"/>
-              <a:t>~93% English</a:t>
-            </a:r>
-            <a:r>
-              <a:rPr b="0" sz="1800"/>
-              <a:t> → straight SFT yields a strong English model with weak EU coverage</a:t>
+              <a:t>OpenJury</a:t>
             </a:r>
           </a:p>
           <a:p>
             <a:pPr/>
             <a:r>
               <a:rPr b="0" sz="1800"/>
-              <a:t>Two-pronged plan:</a:t>
+              <a:t>Kicking off continued SFT on English + EU mixes (90/80/70 % English) to fix the Dolci ~93%-English skew </a:t>
+            </a:r>
+            <a:r>
+              <a:rPr b="1" sz="1800"/>
+              <a:t>Since then:</a:t>
             </a:r>
           </a:p>
           <a:p>
             <a:pPr/>
             <a:r>
+              <a:rPr b="0" sz="1800"/>
+              <a:t>Closed the full </a:t>
+            </a:r>
+            <a:r>
               <a:rPr b="1" sz="1800"/>
-              <a:t>Continued SFT</a:t>
-            </a:r>
-            <a:r>
-              <a:rPr b="0" sz="1800"/>
-              <a:t> of the OLMo-3-7B Instruct checkpoint on English + EU mixes (this is what most of today's results are about)</a:t>
+              <a:t>multilingual_eu Tracks A–F</a:t>
+            </a:r>
+            <a:r>
+              <a:rPr b="0" sz="1800"/>
+              <a:t> sweep (ratios, scale, English-replay, extreme ratios)</a:t>
             </a:r>
           </a:p>
           <a:p>
             <a:pPr/>
             <a:r>
               <a:rPr b="0" sz="1800"/>
-              <a:t>Apply the same recipe to the </a:t>
+              <a:t>Switched to </a:t>
             </a:r>
             <a:r>
               <a:rPr b="1" sz="1800"/>
-              <a:t>OpenEuroLLM 9B alpha</a:t>
-            </a:r>
-            <a:r>
-              <a:rPr b="0" sz="1800"/>
-              <a:t> (`datamix-9b-80-20`) once it lands, to see whether multilingual-pretraining + multilingual-SFT compound</a:t>
+              <a:t>high-quality gemma-3-27b-it Dolci translations</a:t>
+            </a:r>
+            <a:r>
+              <a:rPr b="0" sz="1800"/>
+              <a:t> (replaces NLLB-distilled-600M) → headline win</a:t>
             </a:r>
           </a:p>
           <a:p>
             <a:pPr/>
             <a:r>
               <a:rPr b="0" sz="1800"/>
-              <a:t>Evaluation throughout: </a:t>
+              <a:t>First </a:t>
             </a:r>
             <a:r>
               <a:rPr b="1" sz="1800"/>
-              <a:t>LLM-as-a-judge with Qwen3.5-27B</a:t>
-            </a:r>
-            <a:r>
-              <a:rPr b="0" sz="1800"/>
-              <a:t>, LMArena-style Bradley–Terry Elo per language, run via our own open framework </a:t>
-            </a:r>
+              <a:t>Datamix-9B</a:t>
+            </a:r>
+            <a:r>
+              <a:rPr b="0" sz="1800"/>
+              <a:t> post-training results (EuroLLM 9B alpha)</a:t>
+            </a:r>
+          </a:p>
+          <a:p>
+            <a:pPr/>
+            <a:r>
+              <a:rPr b="0" sz="1800"/>
+              <a:t>Public </a:t>
+            </a:r>
+            <a:r>
+              <a:rPr b="1" sz="1800"/>
+              <a:t>qualitative completions viewer</a:t>
+            </a:r>
+            <a:r>
+              <a:rPr b="0" sz="1800"/>
+              <a:t> for the consortium</a:t>
+            </a:r>
+          </a:p>
+          <a:p>
+            <a:pPr/>
             <a:r>
               <a:rPr b="1" sz="1800"/>
               <a:t>JudgeArena</a:t>
             </a:r>
             <a:r>
               <a:rPr b="0" sz="1800"/>
-              <a:t> (NeurIPS submission in progress)</a:t>
+              <a:t> unified judge framework — NeurIPS submission in progress, several new benchmarks</a:t>
             </a:r>
           </a:p>
         </p:txBody>
@@ -3358,7 +3364,7 @@
           <a:lstStyle/>
           <a:p>
             <a:r>
-              <a:t>Slide 2 — Today's update at a glance</a:t>
+              <a:t>Slide 2 — Multilingual EU SFT: what we learned</a:t>
             </a:r>
           </a:p>
         </p:txBody>
@@ -3380,72 +3386,52 @@
           <a:p>
             <a:pPr/>
             <a:r>
-              <a:rPr b="0" sz="1800"/>
-              <a:t>Closed the multilingual_eu </a:t>
-            </a:r>
-            <a:r>
               <a:rPr b="1" sz="1800"/>
-              <a:t>Tracks A–F</a:t>
-            </a:r>
-            <a:r>
-              <a:rPr b="0" sz="1800"/>
-              <a:t> sweep (English/EU ratio, data scale, English-replay)</a:t>
+              <a:t>Replaying the base SFT's English data</a:t>
+            </a:r>
+            <a:r>
+              <a:rPr b="0" sz="1800"/>
+              <a:t> is the unlock: keeps English Elo at the baseline level (~950) instead of collapsing to ~770</a:t>
             </a:r>
           </a:p>
           <a:p>
             <a:pPr/>
             <a:r>
-              <a:rPr b="0" sz="1800"/>
-              <a:t>New runs on </a:t>
-            </a:r>
-            <a:r>
               <a:rPr b="1" sz="1800"/>
-              <a:t>high-quality gemma-3-27b-it Dolci translations</a:t>
-            </a:r>
-            <a:r>
-              <a:rPr b="0" sz="1800"/>
-              <a:t> (vs. NLLB-distilled before)</a:t>
+              <a:t>Sweet spot ≈ 75/25 English/EU</a:t>
+            </a:r>
+            <a:r>
+              <a:rPr b="0" sz="1800"/>
+              <a:t> for overall Elo across 12 EU langs; pure-EU collapses both English *and* EU</a:t>
             </a:r>
           </a:p>
           <a:p>
             <a:pPr/>
             <a:r>
-              <a:rPr b="0" sz="1800"/>
-              <a:t>First </a:t>
-            </a:r>
-            <a:r>
               <a:rPr b="1" sz="1800"/>
-              <a:t>Datamix-9B</a:t>
-            </a:r>
-            <a:r>
-              <a:rPr b="0" sz="1800"/>
-              <a:t> post-training results (the EuroLLM 9B alpha)</a:t>
+              <a:t>Continued SFT itself causes English forgetting</a:t>
+            </a:r>
+            <a:r>
+              <a:rPr b="0" sz="1800"/>
+              <a:t> — even a 100% English continued-SFT (no EU at all) drops English Elo</a:t>
             </a:r>
           </a:p>
           <a:p>
             <a:pPr/>
             <a:r>
-              <a:rPr b="0" sz="1800"/>
-              <a:t>Public </a:t>
-            </a:r>
-            <a:r>
               <a:rPr b="1" sz="1800"/>
-              <a:t>qualitative completions viewer</a:t>
-            </a:r>
-            <a:r>
-              <a:rPr b="0" sz="1800"/>
-              <a:t> for the consortium and partners</a:t>
+              <a:t>Cross-lingual transfer</a:t>
+            </a:r>
+            <a:r>
+              <a:rPr b="0" sz="1800"/>
+              <a:t>: Romanian (held-out, Latin script) transfers cleanly; Greek (different script) does not</a:t>
             </a:r>
           </a:p>
           <a:p>
             <a:pPr/>
             <a:r>
-              <a:rPr b="1" sz="1800"/>
-              <a:t>JudgeArena</a:t>
-            </a:r>
-            <a:r>
-              <a:rPr b="0" sz="1800"/>
-              <a:t> writeup in progress; new benchmarks integrated</a:t>
+              <a:rPr b="0" sz="1800"/>
+              <a:t>Net: the *source* of the English replay matters more than the exact ratio</a:t>
             </a:r>
           </a:p>
         </p:txBody>
@@ -3484,7 +3470,7 @@
           <a:lstStyle/>
           <a:p>
             <a:r>
-              <a:t>Slide 3 — Multilingual EU SFT: what we learned</a:t>
+              <a:t>Slide 3 — Dolci-Translated SFT (the headline win)</a:t>
             </a:r>
           </a:p>
         </p:txBody>
@@ -3506,52 +3492,75 @@
           <a:p>
             <a:pPr/>
             <a:r>
+              <a:rPr b="0" sz="1800"/>
+              <a:t>New translated data: `openeurollm/Dolci-Instruct-SFT-translated` — </a:t>
+            </a:r>
+            <a:r>
               <a:rPr b="1" sz="1800"/>
-              <a:t>Replaying the base SFT's English data</a:t>
-            </a:r>
-            <a:r>
-              <a:rPr b="0" sz="1800"/>
-              <a:t> is the unlock: keeps English Elo at the baseline level (~950) instead of collapsing to ~770</a:t>
+              <a:t>gemma-3-27b-it</a:t>
+            </a:r>
+            <a:r>
+              <a:rPr b="0" sz="1800"/>
+              <a:t> translations of Dolci into 7 EU langs (cs, de, es, fi, fr, it, sv)</a:t>
             </a:r>
           </a:p>
           <a:p>
             <a:pPr/>
             <a:r>
+              <a:rPr b="0" sz="1800"/>
+              <a:t>Two ratios run </a:t>
+            </a:r>
+            <a:r>
               <a:rPr b="1" sz="1800"/>
-              <a:t>Sweet spot ≈ 75/25 English/EU</a:t>
-            </a:r>
-            <a:r>
-              <a:rPr b="0" sz="1800"/>
-              <a:t> for overall Elo across 12 EU langs; pure-EU collapses both English *and* EU</a:t>
+              <a:t>at matched compute</a:t>
+            </a:r>
+            <a:r>
+              <a:rPr b="0" sz="1800"/>
+              <a:t> (same 2.87M samples × 2 epochs, identical hyperparams) so we isolate ratio from compute:</a:t>
             </a:r>
           </a:p>
           <a:p>
             <a:pPr/>
             <a:r>
               <a:rPr b="1" sz="1800"/>
-              <a:t>Continued SFT itself causes English forgetting</a:t>
-            </a:r>
-            <a:r>
-              <a:rPr b="0" sz="1800"/>
-              <a:t> — even a 100% English continued-SFT (no EU at all) drops English Elo</a:t>
+              <a:t>75% English / 25% translated</a:t>
+            </a:r>
+            <a:r>
+              <a:rPr b="0" sz="1800"/>
+              <a:t> preserves English perfectly (within CI of baseline) and lifts non-English Elo from 697 → 755</a:t>
             </a:r>
           </a:p>
           <a:p>
             <a:pPr/>
             <a:r>
               <a:rPr b="1" sz="1800"/>
-              <a:t>Cross-lingual transfer</a:t>
-            </a:r>
-            <a:r>
-              <a:rPr b="0" sz="1800"/>
-              <a:t>: Romanian (held-out, Latin script) transfers cleanly; Greek (different script) does not</a:t>
+              <a:t>25% English / 75% translated</a:t>
+            </a:r>
+            <a:r>
+              <a:rPr b="0" sz="1800"/>
+              <a:t> wins on most non-English; </a:t>
+            </a:r>
+            <a:r>
+              <a:rPr b="1" sz="1800"/>
+              <a:t>Finnish +125 Elo</a:t>
+            </a:r>
+            <a:r>
+              <a:rPr b="0" sz="1800"/>
+              <a:t> over baseline; English costs ~37 pts</a:t>
             </a:r>
           </a:p>
           <a:p>
             <a:pPr/>
             <a:r>
               <a:rPr b="0" sz="1800"/>
-              <a:t>Net: the *source* of the English replay matters more than the exact ratio</a:t>
+              <a:t>High-quality MT closes the gap NLLB-distilled-600M couldn't — translation quality was the bottleneck</a:t>
+            </a:r>
+          </a:p>
+          <a:p>
+            <a:pPr/>
+            <a:r>
+              <a:rPr b="0" sz="1800"/>
+              <a:t>Next: Konstantin's quality filter on the translated pool, then the Think-SFT analogue</a:t>
             </a:r>
           </a:p>
         </p:txBody>
@@ -3590,7 +3599,7 @@
           <a:lstStyle/>
           <a:p>
             <a:r>
-              <a:t>Slide 4 — Dolci-Translated SFT (the headline win)</a:t>
+              <a:t>Slide 4 — Qualitative viewer for the consortium</a:t>
             </a:r>
           </a:p>
         </p:txBody>
@@ -3613,74 +3622,44 @@
             <a:pPr/>
             <a:r>
               <a:rPr b="0" sz="1800"/>
-              <a:t>New translated data: `openeurollm/Dolci-Instruct-SFT-translated` — </a:t>
+              <a:t>Public site: https://ferreirafabio.github.io/olmo3-multilingual-dolci-sft-progression/ (HF Space mirror)</a:t>
+            </a:r>
+          </a:p>
+          <a:p>
+            <a:pPr/>
+            <a:r>
+              <a:rPr b="0" sz="1800"/>
+              <a:t>12 checkpoints (base / SFT-baseline / 75-en × 5 / 25-en × 5) × 7 EU langs × </a:t>
             </a:r>
             <a:r>
               <a:rPr b="1" sz="1800"/>
-              <a:t>gemma-3-27b-it</a:t>
-            </a:r>
-            <a:r>
-              <a:rPr b="0" sz="1800"/>
-              <a:t> translations of Dolci into 7 EU langs (cs, de, es, fi, fr, it, sv)</a:t>
+              <a:t>698 LMArena prompts</a:t>
+            </a:r>
+            <a:r>
+              <a:rPr b="0" sz="1800"/>
+              <a:t>, stratified by 9 LMArena category tags (math, IF, creativity, …)</a:t>
             </a:r>
           </a:p>
           <a:p>
             <a:pPr/>
             <a:r>
               <a:rPr b="0" sz="1800"/>
-              <a:t>Two ratios run </a:t>
+              <a:t>Slider scrubs training progression in lockstep across the two SFT runs; category-filter pills; dark/light theme</a:t>
+            </a:r>
+          </a:p>
+          <a:p>
+            <a:pPr/>
+            <a:r>
+              <a:rPr b="0" sz="1800"/>
+              <a:t>Lets partners (e.g. AI Sweden) </a:t>
             </a:r>
             <a:r>
               <a:rPr b="1" sz="1800"/>
-              <a:t>at matched compute</a:t>
-            </a:r>
-            <a:r>
-              <a:rPr b="0" sz="1800"/>
-              <a:t> (same 2.87M samples × 2 epochs, identical hyperparams) so we isolate ratio from compute:</a:t>
-            </a:r>
-          </a:p>
-          <a:p>
-            <a:pPr/>
-            <a:r>
-              <a:rPr b="1" sz="1800"/>
-              <a:t>75% English / 25% translated</a:t>
-            </a:r>
-            <a:r>
-              <a:rPr b="0" sz="1800"/>
-              <a:t> preserves English perfectly (within CI of baseline) and lifts non-English Elo from 697 → 755</a:t>
-            </a:r>
-          </a:p>
-          <a:p>
-            <a:pPr/>
-            <a:r>
-              <a:rPr b="1" sz="1800"/>
-              <a:t>25% English / 75% translated</a:t>
-            </a:r>
-            <a:r>
-              <a:rPr b="0" sz="1800"/>
-              <a:t> wins on most non-English; </a:t>
-            </a:r>
-            <a:r>
-              <a:rPr b="1" sz="1800"/>
-              <a:t>Finnish +125 Elo</a:t>
-            </a:r>
-            <a:r>
-              <a:rPr b="0" sz="1800"/>
-              <a:t> over baseline; English costs ~37 pts</a:t>
-            </a:r>
-          </a:p>
-          <a:p>
-            <a:pPr/>
-            <a:r>
-              <a:rPr b="0" sz="1800"/>
-              <a:t>High-quality MT closes the gap NLLB-distilled-600M couldn't — translation quality was the bottleneck</a:t>
-            </a:r>
-          </a:p>
-          <a:p>
-            <a:pPr/>
-            <a:r>
-              <a:rPr b="0" sz="1800"/>
-              <a:t>Next: Konstantin's quality filter on the translated pool, then the Think-SFT analogue</a:t>
+              <a:t>eyeball completion quality per language</a:t>
+            </a:r>
+            <a:r>
+              <a:rPr b="0" sz="1800"/>
+              <a:t> alongside the numerical Elo</a:t>
             </a:r>
           </a:p>
         </p:txBody>
@@ -3719,7 +3698,7 @@
           <a:lstStyle/>
           <a:p>
             <a:r>
-              <a:t>Slide 5 — Qualitative viewer for the consortium</a:t>
+              <a:t>Slide 5 — Datamix-9B Instruct SFT (OpenEuroLLM 9B alpha)</a:t>
             </a:r>
           </a:p>
         </p:txBody>
@@ -3742,44 +3721,43 @@
             <a:pPr/>
             <a:r>
               <a:rPr b="0" sz="1800"/>
-              <a:t>Public site: https://ferreirafabio.github.io/olmo3-multilingual-dolci-sft-progression/ (HF Space mirror)</a:t>
+              <a:t>First post-training of `openeurollm/datamix-9b-80-20` (Llama arch, Gemma tokenizer, 4B-token 80/20 multilingual pretraining)</a:t>
             </a:r>
           </a:p>
           <a:p>
             <a:pPr/>
             <a:r>
               <a:rPr b="0" sz="1800"/>
-              <a:t>12 checkpoints (base / SFT-baseline / 75-en × 5 / 25-en × 5) × 7 EU langs × </a:t>
-            </a:r>
+              <a:t>Same recipe as OLMo's 75/25-en mix, judged with Qwen3.5-27B (500 battles/lang)</a:t>
+            </a:r>
+          </a:p>
+          <a:p>
+            <a:pPr/>
             <a:r>
               <a:rPr b="1" sz="1800"/>
-              <a:t>698 LMArena prompts</a:t>
-            </a:r>
-            <a:r>
-              <a:rPr b="0" sz="1800"/>
-              <a:t>, stratified by 9 LMArena category tags (math, IF, creativity, …)</a:t>
+              <a:t>Beats our OLMo 75/25 on 4/7 non-English</a:t>
+            </a:r>
+            <a:r>
+              <a:rPr b="0" sz="1800"/>
+              <a:t> at fair 1024/1024 truncation: cs +100, de +50, fi +63, sv +34 Elo</a:t>
             </a:r>
           </a:p>
           <a:p>
             <a:pPr/>
             <a:r>
-              <a:rPr b="0" sz="1800"/>
-              <a:t>Slider scrubs training progression in lockstep across the two SFT runs; category-filter pills; dark/light theme</a:t>
+              <a:rPr b="1" sz="1800"/>
+              <a:t>Czech 833±15</a:t>
+            </a:r>
+            <a:r>
+              <a:rPr b="0" sz="1800"/>
+              <a:t> — highest non-English Elo across all our SFTs → multilingual pretraining datamix carries through</a:t>
             </a:r>
           </a:p>
           <a:p>
             <a:pPr/>
             <a:r>
               <a:rPr b="0" sz="1800"/>
-              <a:t>Lets partners (e.g. AI Sweden) </a:t>
-            </a:r>
-            <a:r>
-              <a:rPr b="1" sz="1800"/>
-              <a:t>eyeball completion quality per language</a:t>
-            </a:r>
-            <a:r>
-              <a:rPr b="0" sz="1800"/>
-              <a:t> alongside the numerical Elo</a:t>
+              <a:t>English weaker (2048 ctx limit, alpha pretraining); judge has mild brevity bias — reran OLMo at matched ctx for fairness</a:t>
             </a:r>
           </a:p>
         </p:txBody>
@@ -3818,7 +3796,7 @@
           <a:lstStyle/>
           <a:p>
             <a:r>
-              <a:t>Slide 6 — Datamix-9B Instruct SFT (OpenEuroLLM 9B alpha)</a:t>
+              <a:t>Slide 6 — JudgeArena (NeurIPS)</a:t>
             </a:r>
           </a:p>
         </p:txBody>
@@ -3841,43 +3819,89 @@
             <a:pPr/>
             <a:r>
               <a:rPr b="0" sz="1800"/>
-              <a:t>First post-training of `openeurollm/datamix-9b-80-20` (Llama arch, Gemma tokenizer, 4B-token 80/20 multilingual pretraining)</a:t>
+              <a:t>Open-source unified framework for LLM-judge evaluation</a:t>
             </a:r>
           </a:p>
           <a:p>
             <a:pPr/>
             <a:r>
               <a:rPr b="0" sz="1800"/>
-              <a:t>Same recipe as OLMo's 75/25-en mix, judged with Qwen3.5-27B (500 battles/lang)</a:t>
+              <a:t>Benchmarks: AlpacaEval, Arena-Hard v0.1/v2.0, MT-Bench, </a:t>
+            </a:r>
+            <a:r>
+              <a:rPr b="1" sz="1800"/>
+              <a:t>m-Arena-Hard v0.1/v2.0</a:t>
+            </a:r>
+            <a:r>
+              <a:rPr b="0" sz="1800"/>
+              <a:t> (23 langs)</a:t>
             </a:r>
           </a:p>
           <a:p>
             <a:pPr/>
             <a:r>
+              <a:rPr b="0" sz="1800"/>
+              <a:t>Any vLLM / llama.cpp / OpenRouter model can be </a:t>
+            </a:r>
+            <a:r>
               <a:rPr b="1" sz="1800"/>
-              <a:t>Beats our OLMo 75/25 on 4/7 non-English</a:t>
-            </a:r>
-            <a:r>
-              <a:rPr b="0" sz="1800"/>
-              <a:t> at fair 1024/1024 truncation: cs +100, de +50, fi +63, sv +34 Elo</a:t>
+              <a:t>either contestant or judge</a:t>
+            </a:r>
+            <a:r>
+              <a:rPr b="0" sz="1800"/>
+              <a:t> — single interface, full reproducibility metadata</a:t>
             </a:r>
           </a:p>
           <a:p>
             <a:pPr/>
             <a:r>
+              <a:rPr b="0" sz="1800"/>
+              <a:t>Tuned </a:t>
+            </a:r>
+            <a:r>
               <a:rPr b="1" sz="1800"/>
-              <a:t>Czech 833±15</a:t>
-            </a:r>
-            <a:r>
-              <a:rPr b="0" sz="1800"/>
-              <a:t> — highest non-English Elo across all our SFTs → multilingual pretraining datamix carries through</a:t>
+              <a:t>open-weight judges</a:t>
+            </a:r>
+            <a:r>
+              <a:rPr b="0" sz="1800"/>
+              <a:t> match closed-model judges in meta-eval against human-preference data (EN + multilingual)</a:t>
             </a:r>
           </a:p>
           <a:p>
             <a:pPr/>
             <a:r>
               <a:rPr b="0" sz="1800"/>
-              <a:t>English weaker (2048 ctx limit, alpha pretraining); judge has mild brevity bias — reran OLMo at matched ctx for fairness</a:t>
+              <a:t>New: </a:t>
+            </a:r>
+            <a:r>
+              <a:rPr b="1" sz="1800"/>
+              <a:t>simulated LMArena Elo</a:t>
+            </a:r>
+            <a:r>
+              <a:rPr b="0" sz="1800"/>
+              <a:t> by combining existing human annotations with LLM-judge eval of a target model — within ±MAE pts of LMArena (LOO over 20 models)</a:t>
+            </a:r>
+          </a:p>
+          <a:p>
+            <a:pPr/>
+            <a:r>
+              <a:rPr b="0" sz="1800"/>
+              <a:t>Adds </a:t>
+            </a:r>
+            <a:r>
+              <a:rPr b="1" sz="1800"/>
+              <a:t>fluency-completion mode</a:t>
+            </a:r>
+            <a:r>
+              <a:rPr b="0" sz="1800"/>
+              <a:t> for evaluating *base* models (no chat template) in fi, fr, de, es, sv</a:t>
+            </a:r>
+          </a:p>
+          <a:p>
+            <a:pPr/>
+            <a:r>
+              <a:rPr b="0" sz="1800"/>
+              <a:t>All numbers in this update were produced through this pipeline</a:t>
             </a:r>
           </a:p>
         </p:txBody>
@@ -3891,150 +3915,6 @@
 </file>
 
 <file path=ppt/slides/slide8.xml><?xml version="1.0" encoding="utf-8"?>
-<p:sld xmlns:a="http://schemas.openxmlformats.org/drawingml/2006/main" xmlns:p="http://schemas.openxmlformats.org/presentationml/2006/main" xmlns:r="http://schemas.openxmlformats.org/officeDocument/2006/relationships">
-  <p:cSld>
-    <p:spTree>
-      <p:nvGrpSpPr>
-        <p:cNvPr id="1" name=""/>
-        <p:cNvGrpSpPr/>
-        <p:nvPr/>
-      </p:nvGrpSpPr>
-      <p:grpSpPr/>
-      <p:sp>
-        <p:nvSpPr>
-          <p:cNvPr id="2" name="Title 1"/>
-          <p:cNvSpPr>
-            <a:spLocks noGrp="1"/>
-          </p:cNvSpPr>
-          <p:nvPr>
-            <p:ph type="title"/>
-          </p:nvPr>
-        </p:nvSpPr>
-        <p:spPr/>
-        <p:txBody>
-          <a:bodyPr/>
-          <a:lstStyle/>
-          <a:p>
-            <a:r>
-              <a:t>Slide 7 — JudgeArena (NeurIPS)</a:t>
-            </a:r>
-          </a:p>
-        </p:txBody>
-      </p:sp>
-      <p:sp>
-        <p:nvSpPr>
-          <p:cNvPr id="3" name="Content Placeholder 2"/>
-          <p:cNvSpPr>
-            <a:spLocks noGrp="1"/>
-          </p:cNvSpPr>
-          <p:nvPr>
-            <p:ph idx="1"/>
-          </p:nvPr>
-        </p:nvSpPr>
-        <p:spPr/>
-        <p:txBody>
-          <a:bodyPr/>
-          <a:lstStyle/>
-          <a:p>
-            <a:pPr/>
-            <a:r>
-              <a:rPr b="0" sz="1800"/>
-              <a:t>Open-source unified framework for LLM-judge evaluation</a:t>
-            </a:r>
-          </a:p>
-          <a:p>
-            <a:pPr/>
-            <a:r>
-              <a:rPr b="0" sz="1800"/>
-              <a:t>Benchmarks: AlpacaEval, Arena-Hard v0.1/v2.0, MT-Bench, </a:t>
-            </a:r>
-            <a:r>
-              <a:rPr b="1" sz="1800"/>
-              <a:t>m-Arena-Hard v0.1/v2.0</a:t>
-            </a:r>
-            <a:r>
-              <a:rPr b="0" sz="1800"/>
-              <a:t> (23 langs)</a:t>
-            </a:r>
-          </a:p>
-          <a:p>
-            <a:pPr/>
-            <a:r>
-              <a:rPr b="0" sz="1800"/>
-              <a:t>Any vLLM / llama.cpp / OpenRouter model can be </a:t>
-            </a:r>
-            <a:r>
-              <a:rPr b="1" sz="1800"/>
-              <a:t>either contestant or judge</a:t>
-            </a:r>
-            <a:r>
-              <a:rPr b="0" sz="1800"/>
-              <a:t> — single interface, full reproducibility metadata</a:t>
-            </a:r>
-          </a:p>
-          <a:p>
-            <a:pPr/>
-            <a:r>
-              <a:rPr b="0" sz="1800"/>
-              <a:t>Tuned </a:t>
-            </a:r>
-            <a:r>
-              <a:rPr b="1" sz="1800"/>
-              <a:t>open-weight judges</a:t>
-            </a:r>
-            <a:r>
-              <a:rPr b="0" sz="1800"/>
-              <a:t> match closed-model judges in meta-eval against human-preference data (EN + multilingual)</a:t>
-            </a:r>
-          </a:p>
-          <a:p>
-            <a:pPr/>
-            <a:r>
-              <a:rPr b="0" sz="1800"/>
-              <a:t>New: </a:t>
-            </a:r>
-            <a:r>
-              <a:rPr b="1" sz="1800"/>
-              <a:t>simulated LMArena Elo</a:t>
-            </a:r>
-            <a:r>
-              <a:rPr b="0" sz="1800"/>
-              <a:t> by combining existing human annotations with LLM-judge eval of a target model — within ±MAE pts of LMArena (LOO over 20 models)</a:t>
-            </a:r>
-          </a:p>
-          <a:p>
-            <a:pPr/>
-            <a:r>
-              <a:rPr b="0" sz="1800"/>
-              <a:t>Adds </a:t>
-            </a:r>
-            <a:r>
-              <a:rPr b="1" sz="1800"/>
-              <a:t>fluency-completion mode</a:t>
-            </a:r>
-            <a:r>
-              <a:rPr b="0" sz="1800"/>
-              <a:t> for evaluating *base* models (no chat template) in fi, fr, de, es, sv</a:t>
-            </a:r>
-          </a:p>
-          <a:p>
-            <a:pPr/>
-            <a:r>
-              <a:rPr b="0" sz="1800"/>
-              <a:t>All numbers in this update were produced through this pipeline</a:t>
-            </a:r>
-          </a:p>
-        </p:txBody>
-      </p:sp>
-    </p:spTree>
-  </p:cSld>
-  <p:clrMapOvr>
-    <a:masterClrMapping/>
-  </p:clrMapOvr>
-</p:sld>
-</file>
-
-<file path=ppt/slides/slide9.xml><?xml version="1.0" encoding="utf-8"?>
 <p:sld xmlns:a="http://schemas.openxmlformats.org/drawingml/2006/main" xmlns:p="http://schemas.openxmlformats.org/presentationml/2006/main" xmlns:r="http://schemas.openxmlformats.org/officeDocument/2006/relationships">
   <p:cSld>
     <p:spTree>

</xml_diff>

<commit_message>
Rewrite 2026-04-28 deck in fluent prose, slim Slide 1 to recap
- Slide 1 is now a pure recap of the March talk + a one-line lead-in;
  details land in their own slides instead of being previewed twice
- Remaining slides converted from telegraphic bullets to fluent
  prose-style bullets readable cold
- Drop the Asks section

Co-Authored-By: Claude Opus 4.7 <noreply@anthropic.com>
</commit_message>
<xml_diff>
--- a/oellm/meetings/llms4eu_wp4/2026-04-28.pptx
+++ b/oellm/meetings/llms4eu_wp4/2026-04-28.pptx
@@ -12,7 +12,6 @@
     <p:sldId id="260" r:id="rId11"/>
     <p:sldId id="261" r:id="rId12"/>
     <p:sldId id="262" r:id="rId13"/>
-    <p:sldId id="263" r:id="rId14"/>
   </p:sldIdLst>
   <p:sldSz cx="12191695" cy="6858000" type="screen4x3"/>
   <p:notesSz cx="6858000" cy="9144000"/>
@@ -3201,7 +3200,7 @@
           <a:lstStyle/>
           <a:p>
             <a:r>
-              <a:t>Slide 1 — Where we left off &amp; what's new</a:t>
+              <a:t>Slide 1 — Where we left off (March)</a:t>
             </a:r>
           </a:p>
         </p:txBody>
@@ -3224,7 +3223,7 @@
             <a:pPr/>
             <a:r>
               <a:rPr b="0" sz="1800"/>
-              <a:t>Reproduced </a:t>
+              <a:t>We had just reproduced </a:t>
             </a:r>
             <a:r>
               <a:rPr b="1" sz="1800"/>
@@ -3232,14 +3231,7 @@
             </a:r>
             <a:r>
               <a:rPr b="0" sz="1800"/>
-              <a:t> as our controllable starting checkpoint</a:t>
-            </a:r>
-          </a:p>
-          <a:p>
-            <a:pPr/>
-            <a:r>
-              <a:rPr b="0" sz="1800"/>
-              <a:t>Validated with LLM-as-a-judge (Qwen3-30B-A3B) via </a:t>
+              <a:t> as a controllable starting checkpoint and validated it with LLM-as-a-judge (Qwen3-30B-A3B) through </a:t>
             </a:r>
             <a:r>
               <a:rPr b="1" sz="1800"/>
@@ -3250,82 +3242,22 @@
             <a:pPr/>
             <a:r>
               <a:rPr b="0" sz="1800"/>
-              <a:t>Kicking off continued SFT on English + EU mixes (90/80/70 % English) to fix the Dolci ~93%-English skew </a:t>
+              <a:t>The plan was to begin </a:t>
             </a:r>
             <a:r>
               <a:rPr b="1" sz="1800"/>
-              <a:t>Since then:</a:t>
+              <a:t>continued SFT on English + EU mixes</a:t>
+            </a:r>
+            <a:r>
+              <a:rPr b="0" sz="1800"/>
+              <a:t> (90/80/70 % English) to fix the ~93%-English skew of the Dolci data</a:t>
             </a:r>
           </a:p>
           <a:p>
             <a:pPr/>
             <a:r>
               <a:rPr b="0" sz="1800"/>
-              <a:t>Closed the full </a:t>
-            </a:r>
-            <a:r>
-              <a:rPr b="1" sz="1800"/>
-              <a:t>multilingual_eu Tracks A–F</a:t>
-            </a:r>
-            <a:r>
-              <a:rPr b="0" sz="1800"/>
-              <a:t> sweep (ratios, scale, English-replay, extreme ratios)</a:t>
-            </a:r>
-          </a:p>
-          <a:p>
-            <a:pPr/>
-            <a:r>
-              <a:rPr b="0" sz="1800"/>
-              <a:t>Switched to </a:t>
-            </a:r>
-            <a:r>
-              <a:rPr b="1" sz="1800"/>
-              <a:t>high-quality gemma-3-27b-it Dolci translations</a:t>
-            </a:r>
-            <a:r>
-              <a:rPr b="0" sz="1800"/>
-              <a:t> (replaces NLLB-distilled-600M) → headline win</a:t>
-            </a:r>
-          </a:p>
-          <a:p>
-            <a:pPr/>
-            <a:r>
-              <a:rPr b="0" sz="1800"/>
-              <a:t>First </a:t>
-            </a:r>
-            <a:r>
-              <a:rPr b="1" sz="1800"/>
-              <a:t>Datamix-9B</a:t>
-            </a:r>
-            <a:r>
-              <a:rPr b="0" sz="1800"/>
-              <a:t> post-training results (EuroLLM 9B alpha)</a:t>
-            </a:r>
-          </a:p>
-          <a:p>
-            <a:pPr/>
-            <a:r>
-              <a:rPr b="0" sz="1800"/>
-              <a:t>Public </a:t>
-            </a:r>
-            <a:r>
-              <a:rPr b="1" sz="1800"/>
-              <a:t>qualitative completions viewer</a:t>
-            </a:r>
-            <a:r>
-              <a:rPr b="0" sz="1800"/>
-              <a:t> for the consortium</a:t>
-            </a:r>
-          </a:p>
-          <a:p>
-            <a:pPr/>
-            <a:r>
-              <a:rPr b="1" sz="1800"/>
-              <a:t>JudgeArena</a:t>
-            </a:r>
-            <a:r>
-              <a:rPr b="0" sz="1800"/>
-              <a:t> unified judge framework — NeurIPS submission in progress, several new benchmarks</a:t>
+              <a:t>Today I'll walk through what came out of that, plus a few new threads that opened up since</a:t>
             </a:r>
           </a:p>
         </p:txBody>
@@ -3386,52 +3318,44 @@
           <a:p>
             <a:pPr/>
             <a:r>
+              <a:rPr b="0" sz="1800"/>
+              <a:t>Replaying the base SFT's own English data is the unlock — it keeps English Elo at the baseline level (~950) instead of letting it collapse to ~770</a:t>
+            </a:r>
+          </a:p>
+          <a:p>
+            <a:pPr/>
+            <a:r>
+              <a:rPr b="0" sz="1800"/>
+              <a:t>Across 12 EU languages the sweet spot sits at roughly </a:t>
+            </a:r>
+            <a:r>
               <a:rPr b="1" sz="1800"/>
-              <a:t>Replaying the base SFT's English data</a:t>
+              <a:t>75% English / 25% EU</a:t>
             </a:r>
             <a:r>
               <a:rPr b="0" sz="1800"/>
-              <a:t> is the unlock: keeps English Elo at the baseline level (~950) instead of collapsing to ~770</a:t>
+              <a:t>; pushing all the way to pure-EU collapses both English *and* EU performance</a:t>
             </a:r>
           </a:p>
           <a:p>
             <a:pPr/>
             <a:r>
-              <a:rPr b="1" sz="1800"/>
-              <a:t>Sweet spot ≈ 75/25 English/EU</a:t>
-            </a:r>
-            <a:r>
               <a:rPr b="0" sz="1800"/>
-              <a:t> for overall Elo across 12 EU langs; pure-EU collapses both English *and* EU</a:t>
+              <a:t>Continued SFT itself causes English forgetting — even a 100%-English continued-SFT run with no EU data at all still drops English Elo</a:t>
             </a:r>
           </a:p>
           <a:p>
             <a:pPr/>
             <a:r>
-              <a:rPr b="1" sz="1800"/>
-              <a:t>Continued SFT itself causes English forgetting</a:t>
-            </a:r>
-            <a:r>
               <a:rPr b="0" sz="1800"/>
-              <a:t> — even a 100% English continued-SFT (no EU at all) drops English Elo</a:t>
+              <a:t>Cross-lingual transfer is script-dependent: Romanian (held-out, Latin script) transfers cleanly, while Greek does not</a:t>
             </a:r>
           </a:p>
           <a:p>
             <a:pPr/>
             <a:r>
-              <a:rPr b="1" sz="1800"/>
-              <a:t>Cross-lingual transfer</a:t>
-            </a:r>
-            <a:r>
               <a:rPr b="0" sz="1800"/>
-              <a:t>: Romanian (held-out, Latin script) transfers cleanly; Greek (different script) does not</a:t>
-            </a:r>
-          </a:p>
-          <a:p>
-            <a:pPr/>
-            <a:r>
-              <a:rPr b="0" sz="1800"/>
-              <a:t>Net: the *source* of the English replay matters more than the exact ratio</a:t>
+              <a:t>The bottom line is that the *source* of the English replay matters more than the exact English/EU ratio</a:t>
             </a:r>
           </a:p>
         </p:txBody>
@@ -3493,74 +3417,22 @@
             <a:pPr/>
             <a:r>
               <a:rPr b="0" sz="1800"/>
-              <a:t>New translated data: `openeurollm/Dolci-Instruct-SFT-translated` — </a:t>
+              <a:t>On gemma-3-27b-it translations of Dolci into 7 EU languages, two matched-compute runs show that a </a:t>
             </a:r>
             <a:r>
               <a:rPr b="1" sz="1800"/>
-              <a:t>gemma-3-27b-it</a:t>
+              <a:t>75/25 English-to-translated mix preserves English at baseline while lifting non-English Elo from 697 to 755</a:t>
             </a:r>
             <a:r>
               <a:rPr b="0" sz="1800"/>
-              <a:t> translations of Dolci into 7 EU langs (cs, de, es, fi, fr, it, sv)</a:t>
+              <a:t>, and the more aggressive 25/75 mix wins on most non-English (notably Finnish, +125 over baseline) at a ~37-point English cost</a:t>
             </a:r>
           </a:p>
           <a:p>
             <a:pPr/>
             <a:r>
               <a:rPr b="0" sz="1800"/>
-              <a:t>Two ratios run </a:t>
-            </a:r>
-            <a:r>
-              <a:rPr b="1" sz="1800"/>
-              <a:t>at matched compute</a:t>
-            </a:r>
-            <a:r>
-              <a:rPr b="0" sz="1800"/>
-              <a:t> (same 2.87M samples × 2 epochs, identical hyperparams) so we isolate ratio from compute:</a:t>
-            </a:r>
-          </a:p>
-          <a:p>
-            <a:pPr/>
-            <a:r>
-              <a:rPr b="1" sz="1800"/>
-              <a:t>75% English / 25% translated</a:t>
-            </a:r>
-            <a:r>
-              <a:rPr b="0" sz="1800"/>
-              <a:t> preserves English perfectly (within CI of baseline) and lifts non-English Elo from 697 → 755</a:t>
-            </a:r>
-          </a:p>
-          <a:p>
-            <a:pPr/>
-            <a:r>
-              <a:rPr b="1" sz="1800"/>
-              <a:t>25% English / 75% translated</a:t>
-            </a:r>
-            <a:r>
-              <a:rPr b="0" sz="1800"/>
-              <a:t> wins on most non-English; </a:t>
-            </a:r>
-            <a:r>
-              <a:rPr b="1" sz="1800"/>
-              <a:t>Finnish +125 Elo</a:t>
-            </a:r>
-            <a:r>
-              <a:rPr b="0" sz="1800"/>
-              <a:t> over baseline; English costs ~37 pts</a:t>
-            </a:r>
-          </a:p>
-          <a:p>
-            <a:pPr/>
-            <a:r>
-              <a:rPr b="0" sz="1800"/>
-              <a:t>High-quality MT closes the gap NLLB-distilled-600M couldn't — translation quality was the bottleneck</a:t>
-            </a:r>
-          </a:p>
-          <a:p>
-            <a:pPr/>
-            <a:r>
-              <a:rPr b="0" sz="1800"/>
-              <a:t>Next: Konstantin's quality filter on the translated pool, then the Think-SFT analogue</a:t>
+              <a:t>Next: quality-filter the translated pool, then run the Think-SFT analogue</a:t>
             </a:r>
           </a:p>
         </p:txBody>
@@ -3622,44 +3494,14 @@
             <a:pPr/>
             <a:r>
               <a:rPr b="0" sz="1800"/>
-              <a:t>Public site: https://ferreirafabio.github.io/olmo3-multilingual-dolci-sft-progression/ (HF Space mirror)</a:t>
+              <a:t>Public site at https://ferreirafabio.github.io/olmo3-multilingual-dolci-sft-progression/ shows side-by-side completions across 12 checkpoints (base, SFT baseline, and five intermediates each from the 75-en and 25-en runs), 7 EU languages, and 698 LMArena prompts stratified across 9 LMArena category tags (math, instruction-following, creativity, …)</a:t>
             </a:r>
           </a:p>
           <a:p>
             <a:pPr/>
             <a:r>
               <a:rPr b="0" sz="1800"/>
-              <a:t>12 checkpoints (base / SFT-baseline / 75-en × 5 / 25-en × 5) × 7 EU langs × </a:t>
-            </a:r>
-            <a:r>
-              <a:rPr b="1" sz="1800"/>
-              <a:t>698 LMArena prompts</a:t>
-            </a:r>
-            <a:r>
-              <a:rPr b="0" sz="1800"/>
-              <a:t>, stratified by 9 LMArena category tags (math, IF, creativity, …)</a:t>
-            </a:r>
-          </a:p>
-          <a:p>
-            <a:pPr/>
-            <a:r>
-              <a:rPr b="0" sz="1800"/>
-              <a:t>Slider scrubs training progression in lockstep across the two SFT runs; category-filter pills; dark/light theme</a:t>
-            </a:r>
-          </a:p>
-          <a:p>
-            <a:pPr/>
-            <a:r>
-              <a:rPr b="0" sz="1800"/>
-              <a:t>Lets partners (e.g. AI Sweden) </a:t>
-            </a:r>
-            <a:r>
-              <a:rPr b="1" sz="1800"/>
-              <a:t>eyeball completion quality per language</a:t>
-            </a:r>
-            <a:r>
-              <a:rPr b="0" sz="1800"/>
-              <a:t> alongside the numerical Elo</a:t>
+              <a:t>A single slider scrubs training progression in lockstep across the two SFT runs, and category-filter pills plus a dark/light theme make it easy to drill into specific behaviours</a:t>
             </a:r>
           </a:p>
         </p:txBody>
@@ -3721,43 +3563,30 @@
             <a:pPr/>
             <a:r>
               <a:rPr b="0" sz="1800"/>
-              <a:t>First post-training of `openeurollm/datamix-9b-80-20` (Llama arch, Gemma tokenizer, 4B-token 80/20 multilingual pretraining)</a:t>
+              <a:t>We applied the same 75/25 SFT recipe to the </a:t>
+            </a:r>
+            <a:r>
+              <a:rPr b="1" sz="1800"/>
+              <a:t>OpenEuroLLM 9B alpha</a:t>
+            </a:r>
+            <a:r>
+              <a:rPr b="0" sz="1800"/>
+              <a:t> (`datamix-9b-80-20`, a Llama-architecture model with a Gemma tokenizer, pretrained on 4B tokens with an 80/20 English/multilingual mix), judged with Qwen3.5-27B at 500 battles per language</a:t>
             </a:r>
           </a:p>
           <a:p>
             <a:pPr/>
             <a:r>
               <a:rPr b="0" sz="1800"/>
-              <a:t>Same recipe as OLMo's 75/25-en mix, judged with Qwen3.5-27B (500 battles/lang)</a:t>
-            </a:r>
-          </a:p>
-          <a:p>
-            <a:pPr/>
+              <a:t>At matched context length, Datamix-9B </a:t>
+            </a:r>
             <a:r>
               <a:rPr b="1" sz="1800"/>
-              <a:t>Beats our OLMo 75/25 on 4/7 non-English</a:t>
+              <a:t>beats our OLMo 75/25 on most non-English languages</a:t>
             </a:r>
             <a:r>
               <a:rPr b="0" sz="1800"/>
-              <a:t> at fair 1024/1024 truncation: cs +100, de +50, fi +63, sv +34 Elo</a:t>
-            </a:r>
-          </a:p>
-          <a:p>
-            <a:pPr/>
-            <a:r>
-              <a:rPr b="1" sz="1800"/>
-              <a:t>Czech 833±15</a:t>
-            </a:r>
-            <a:r>
-              <a:rPr b="0" sz="1800"/>
-              <a:t> — highest non-English Elo across all our SFTs → multilingual pretraining datamix carries through</a:t>
-            </a:r>
-          </a:p>
-          <a:p>
-            <a:pPr/>
-            <a:r>
-              <a:rPr b="0" sz="1800"/>
-              <a:t>English weaker (2048 ctx limit, alpha pretraining); judge has mild brevity bias — reran OLMo at matched ctx for fairness</a:t>
+              <a:t> — most strikingly on Czech, where it sets the highest non-English Elo we've measured to date — confirming that the multilingual pretraining mix carries through into post-training; English still lags, primarily because of the alpha's 2048-token context limit</a:t>
             </a:r>
           </a:p>
         </p:txBody>
@@ -3819,14 +3648,7 @@
             <a:pPr/>
             <a:r>
               <a:rPr b="0" sz="1800"/>
-              <a:t>Open-source unified framework for LLM-judge evaluation</a:t>
-            </a:r>
-          </a:p>
-          <a:p>
-            <a:pPr/>
-            <a:r>
-              <a:rPr b="0" sz="1800"/>
-              <a:t>Benchmarks: AlpacaEval, Arena-Hard v0.1/v2.0, MT-Bench, </a:t>
+              <a:t>JudgeArena is our open-source framework for LLM-as-a-judge evaluation; it now unifies AlpacaEval, Arena-Hard v0.1/v2.0, MT-Bench, and </a:t>
             </a:r>
             <a:r>
               <a:rPr b="1" sz="1800"/>
@@ -3834,44 +3656,29 @@
             </a:r>
             <a:r>
               <a:rPr b="0" sz="1800"/>
-              <a:t> (23 langs)</a:t>
+              <a:t> (23 languages) behind a single interface, with any vLLM / llama.cpp / OpenRouter model usable as either contestant or judge and full reproducibility metadata logged for every run</a:t>
             </a:r>
           </a:p>
           <a:p>
             <a:pPr/>
             <a:r>
               <a:rPr b="0" sz="1800"/>
-              <a:t>Any vLLM / llama.cpp / OpenRouter model can be </a:t>
+              <a:t>Our </a:t>
             </a:r>
             <a:r>
               <a:rPr b="1" sz="1800"/>
-              <a:t>either contestant or judge</a:t>
+              <a:t>tuned open-weight judges</a:t>
             </a:r>
             <a:r>
               <a:rPr b="0" sz="1800"/>
-              <a:t> — single interface, full reproducibility metadata</a:t>
+              <a:t> match closed-model judges in meta-evaluations against human-preference data, both in English and multilingual settings, removing the need to depend on proprietary judges for headline numbers</a:t>
             </a:r>
           </a:p>
           <a:p>
             <a:pPr/>
             <a:r>
               <a:rPr b="0" sz="1800"/>
-              <a:t>Tuned </a:t>
-            </a:r>
-            <a:r>
-              <a:rPr b="1" sz="1800"/>
-              <a:t>open-weight judges</a:t>
-            </a:r>
-            <a:r>
-              <a:rPr b="0" sz="1800"/>
-              <a:t> match closed-model judges in meta-eval against human-preference data (EN + multilingual)</a:t>
-            </a:r>
-          </a:p>
-          <a:p>
-            <a:pPr/>
-            <a:r>
-              <a:rPr b="0" sz="1800"/>
-              <a:t>New: </a:t>
+              <a:t>A new </a:t>
             </a:r>
             <a:r>
               <a:rPr b="1" sz="1800"/>
@@ -3879,98 +3686,29 @@
             </a:r>
             <a:r>
               <a:rPr b="0" sz="1800"/>
-              <a:t> by combining existing human annotations with LLM-judge eval of a target model — within ±MAE pts of LMArena (LOO over 20 models)</a:t>
+              <a:t> mode combines existing human annotations with an LLM-judge evaluation of a target model and reproduces actual LMArena Elo to within a small per-model error (leave-one-out over 20 models), giving us a low-cost stand-in for full human arena evaluation</a:t>
             </a:r>
           </a:p>
           <a:p>
             <a:pPr/>
             <a:r>
               <a:rPr b="0" sz="1800"/>
-              <a:t>Adds </a:t>
+              <a:t>A </a:t>
             </a:r>
             <a:r>
               <a:rPr b="1" sz="1800"/>
-              <a:t>fluency-completion mode</a:t>
+              <a:t>fluency-completion</a:t>
             </a:r>
             <a:r>
               <a:rPr b="0" sz="1800"/>
-              <a:t> for evaluating *base* models (no chat template) in fi, fr, de, es, sv</a:t>
+              <a:t> mode now lets us evaluate *base* models (no chat template required) in Finnish, French, German, Spanish and Swedish — useful for the EuroLLM pretrained checkpoints</a:t>
             </a:r>
           </a:p>
           <a:p>
             <a:pPr/>
             <a:r>
               <a:rPr b="0" sz="1800"/>
-              <a:t>All numbers in this update were produced through this pipeline</a:t>
-            </a:r>
-          </a:p>
-        </p:txBody>
-      </p:sp>
-    </p:spTree>
-  </p:cSld>
-  <p:clrMapOvr>
-    <a:masterClrMapping/>
-  </p:clrMapOvr>
-</p:sld>
-</file>
-
-<file path=ppt/slides/slide8.xml><?xml version="1.0" encoding="utf-8"?>
-<p:sld xmlns:a="http://schemas.openxmlformats.org/drawingml/2006/main" xmlns:p="http://schemas.openxmlformats.org/presentationml/2006/main" xmlns:r="http://schemas.openxmlformats.org/officeDocument/2006/relationships">
-  <p:cSld>
-    <p:spTree>
-      <p:nvGrpSpPr>
-        <p:cNvPr id="1" name=""/>
-        <p:cNvGrpSpPr/>
-        <p:nvPr/>
-      </p:nvGrpSpPr>
-      <p:grpSpPr/>
-      <p:sp>
-        <p:nvSpPr>
-          <p:cNvPr id="2" name="Title 1"/>
-          <p:cNvSpPr>
-            <a:spLocks noGrp="1"/>
-          </p:cNvSpPr>
-          <p:nvPr>
-            <p:ph type="title"/>
-          </p:nvPr>
-        </p:nvSpPr>
-        <p:spPr/>
-        <p:txBody>
-          <a:bodyPr/>
-          <a:lstStyle/>
-          <a:p>
-            <a:r>
-              <a:t>Asks</a:t>
-            </a:r>
-          </a:p>
-        </p:txBody>
-      </p:sp>
-      <p:sp>
-        <p:nvSpPr>
-          <p:cNvPr id="3" name="Content Placeholder 2"/>
-          <p:cNvSpPr>
-            <a:spLocks noGrp="1"/>
-          </p:cNvSpPr>
-          <p:nvPr>
-            <p:ph idx="1"/>
-          </p:nvPr>
-        </p:nvSpPr>
-        <p:spPr/>
-        <p:txBody>
-          <a:bodyPr/>
-          <a:lstStyle/>
-          <a:p>
-            <a:pPr/>
-            <a:r>
-              <a:rPr b="0" sz="1800"/>
-              <a:t>AI Sweden: status on Dolci-Instruct-SFT translations beyond the current 7 langs?</a:t>
-            </a:r>
-          </a:p>
-          <a:p>
-            <a:pPr/>
-            <a:r>
-              <a:rPr b="0" sz="1800"/>
-              <a:t>Anyone want to plug additional benchmarks into JudgeArena before camera-ready?</a:t>
+              <a:t>All the numbers in this update were produced through this pipeline</a:t>
             </a:r>
           </a:p>
         </p:txBody>

</xml_diff>

<commit_message>
Embed plots in 2026-04-28 deck, match prev-deck high-level style
- Compress slides to a few short bullets (mirrors the March deck style)
  so detail lives in the figure, not in prose
- Extend md_to_pptx.py to handle ![alt](path) images: bullets-and-image
  slides split bullets left / image right; image-only slides full-bleed
- Embed per-slide plots:
    Slide 2  -> fg_per_language_heatmap.png
    Slide 3  -> dolci_translated_per_language_elo.png
    Slide 5  -> datamix_9b_per_language_elo_truncated.png
- Add a References slide ([1]-[5]) so inline ref markers resolve

Co-Authored-By: Claude Opus 4.7 <noreply@anthropic.com>
</commit_message>
<xml_diff>
--- a/oellm/meetings/llms4eu_wp4/2026-04-28.pptx
+++ b/oellm/meetings/llms4eu_wp4/2026-04-28.pptx
@@ -12,6 +12,7 @@
     <p:sldId id="260" r:id="rId11"/>
     <p:sldId id="261" r:id="rId12"/>
     <p:sldId id="262" r:id="rId13"/>
+    <p:sldId id="263" r:id="rId14"/>
   </p:sldIdLst>
   <p:sldSz cx="12191695" cy="6858000" type="screen4x3"/>
   <p:notesSz cx="6858000" cy="9144000"/>
@@ -3139,31 +3140,6 @@
               <a:t>**Slides:** https://docs.google.com/presentation/d/17fm2S4wqtE3fFytk5wfrlrOcI_f1SOqhb_O6QKO4IfU/edit</a:t>
             </a:r>
           </a:p>
-          <a:p>
-            <a:r>
-              <a:t>**References:**</a:t>
-            </a:r>
-          </a:p>
-          <a:p>
-            <a:r>
-              <a:t>- [multilingual_eu Tracks A–F](https://github.com/ferreirafabio/open-instruct/blob/main/oellm/experiments/multilingual_eu/results/multilingual_eu_results.md)</a:t>
-            </a:r>
-          </a:p>
-          <a:p>
-            <a:r>
-              <a:t>- [Dolci-Translated SFT (gemma-3-27b)](https://github.com/ferreirafabio/open-instruct/blob/main/oellm/experiments/multilingual_eu/results/dolci_translated_results.md)</a:t>
-            </a:r>
-          </a:p>
-          <a:p>
-            <a:r>
-              <a:t>- [Datamix-9B Instruct SFT](https://github.com/ferreirafabio/open-instruct/blob/main/oellm/experiments/multilingual_eu/results/datamix_9b_sft_results.md)</a:t>
-            </a:r>
-          </a:p>
-          <a:p>
-            <a:r>
-              <a:t>- [Qualitative viewer](https://ferreirafabio.github.io/olmo3-multilingual-dolci-sft-progression/)</a:t>
-            </a:r>
-          </a:p>
         </p:txBody>
       </p:sp>
     </p:spTree>
@@ -3200,64 +3176,58 @@
           <a:lstStyle/>
           <a:p>
             <a:r>
-              <a:t>Slide 1 — Where we left off (March)</a:t>
-            </a:r>
-          </a:p>
-        </p:txBody>
-      </p:sp>
-      <p:sp>
-        <p:nvSpPr>
-          <p:cNvPr id="3" name="Content Placeholder 2"/>
-          <p:cNvSpPr>
-            <a:spLocks noGrp="1"/>
-          </p:cNvSpPr>
-          <p:nvPr>
-            <p:ph idx="1"/>
-          </p:nvPr>
-        </p:nvSpPr>
-        <p:spPr/>
-        <p:txBody>
-          <a:bodyPr/>
+              <a:t>Slide 1 — Recap</a:t>
+            </a:r>
+          </a:p>
+        </p:txBody>
+      </p:sp>
+      <p:sp>
+        <p:nvSpPr>
+          <p:cNvPr id="3" name="TextBox 2"/>
+          <p:cNvSpPr txBox="1"/>
+          <p:nvPr/>
+        </p:nvSpPr>
+        <p:spPr>
+          <a:xfrm>
+            <a:off x="457200" y="1097280"/>
+            <a:ext cx="11277295" cy="5303520"/>
+          </a:xfrm>
+          <a:prstGeom prst="rect">
+            <a:avLst/>
+          </a:prstGeom>
+          <a:noFill/>
+        </p:spPr>
+        <p:txBody>
+          <a:bodyPr wrap="square">
+            <a:spAutoFit/>
+          </a:bodyPr>
           <a:lstStyle/>
           <a:p>
             <a:pPr/>
             <a:r>
               <a:rPr b="0" sz="1800"/>
-              <a:t>We had just reproduced </a:t>
-            </a:r>
-            <a:r>
-              <a:rPr b="1" sz="1800"/>
-              <a:t>OLMo-3-7B Instruct-SFT</a:t>
-            </a:r>
+              <a:t>• Presenting today on behalf of David and myself</a:t>
+            </a:r>
+          </a:p>
+          <a:p>
+            <a:pPr/>
             <a:r>
               <a:rPr b="0" sz="1800"/>
-              <a:t> as a controllable starting checkpoint and validated it with LLM-as-a-judge (Qwen3-30B-A3B) through </a:t>
-            </a:r>
-            <a:r>
-              <a:rPr b="1" sz="1800"/>
-              <a:t>OpenJury</a:t>
+              <a:t>• Last meeting we had reproduced OLMo-3-7B-Instruct-SFT and validated it with LLM-as-a-judge using OpenJury</a:t>
             </a:r>
           </a:p>
           <a:p>
             <a:pPr/>
             <a:r>
               <a:rPr b="0" sz="1800"/>
-              <a:t>The plan was to begin </a:t>
-            </a:r>
-            <a:r>
-              <a:rPr b="1" sz="1800"/>
-              <a:t>continued SFT on English + EU mixes</a:t>
-            </a:r>
+              <a:t>• Plan was to start continued SFT on mixes of English and EU-language data</a:t>
+            </a:r>
+          </a:p>
+          <a:p>
+            <a:pPr/>
             <a:r>
               <a:rPr b="0" sz="1800"/>
-              <a:t> (90/80/70 % English) to fix the ~93%-English skew of the Dolci data</a:t>
-            </a:r>
-          </a:p>
-          <a:p>
-            <a:pPr/>
-            <a:r>
-              <a:rPr b="0" sz="1800"/>
-              <a:t>Today I'll walk through what came out of that, plus a few new threads that opened up since</a:t>
+              <a:t>• This update covers what came out of that, plus a few new threads</a:t>
             </a:r>
           </a:p>
         </p:txBody>
@@ -3296,70 +3266,86 @@
           <a:lstStyle/>
           <a:p>
             <a:r>
-              <a:t>Slide 2 — Multilingual EU SFT: what we learned</a:t>
-            </a:r>
-          </a:p>
-        </p:txBody>
-      </p:sp>
-      <p:sp>
-        <p:nvSpPr>
-          <p:cNvPr id="3" name="Content Placeholder 2"/>
-          <p:cNvSpPr>
-            <a:spLocks noGrp="1"/>
-          </p:cNvSpPr>
-          <p:nvPr>
-            <p:ph idx="1"/>
-          </p:nvPr>
-        </p:nvSpPr>
-        <p:spPr/>
-        <p:txBody>
-          <a:bodyPr/>
+              <a:t>Slide 2 — Multilingual SFT: language-ratio sweep</a:t>
+            </a:r>
+          </a:p>
+        </p:txBody>
+      </p:sp>
+      <p:sp>
+        <p:nvSpPr>
+          <p:cNvPr id="3" name="TextBox 2"/>
+          <p:cNvSpPr txBox="1"/>
+          <p:nvPr/>
+        </p:nvSpPr>
+        <p:spPr>
+          <a:xfrm>
+            <a:off x="457200" y="1097280"/>
+            <a:ext cx="5501487" cy="5303520"/>
+          </a:xfrm>
+          <a:prstGeom prst="rect">
+            <a:avLst/>
+          </a:prstGeom>
+          <a:noFill/>
+        </p:spPr>
+        <p:txBody>
+          <a:bodyPr wrap="square">
+            <a:spAutoFit/>
+          </a:bodyPr>
           <a:lstStyle/>
           <a:p>
             <a:pPr/>
             <a:r>
-              <a:rPr b="0" sz="1800"/>
-              <a:t>Replaying the base SFT's own English data is the unlock — it keeps English Elo at the baseline level (~950) instead of letting it collapse to ~770</a:t>
+              <a:rPr b="0" sz="1600"/>
+              <a:t>• Continued SFT on different English / EU language ratios [1]</a:t>
             </a:r>
           </a:p>
           <a:p>
             <a:pPr/>
             <a:r>
-              <a:rPr b="0" sz="1800"/>
-              <a:t>Across 12 EU languages the sweet spot sits at roughly </a:t>
-            </a:r>
-            <a:r>
-              <a:rPr b="1" sz="1800"/>
-              <a:t>75% English / 25% EU</a:t>
-            </a:r>
-            <a:r>
-              <a:rPr b="0" sz="1800"/>
-              <a:t>; pushing all the way to pure-EU collapses both English *and* EU performance</a:t>
+              <a:rPr b="0" sz="1600"/>
+              <a:t>• Replaying the base SFT's own English data prevents English forgetting</a:t>
             </a:r>
           </a:p>
           <a:p>
             <a:pPr/>
             <a:r>
-              <a:rPr b="0" sz="1800"/>
-              <a:t>Continued SFT itself causes English forgetting — even a 100%-English continued-SFT run with no EU data at all still drops English Elo</a:t>
+              <a:rPr b="0" sz="1600"/>
+              <a:t>• Sweet spot is around 75% English / 25% EU</a:t>
             </a:r>
           </a:p>
           <a:p>
             <a:pPr/>
             <a:r>
-              <a:rPr b="0" sz="1800"/>
-              <a:t>Cross-lingual transfer is script-dependent: Romanian (held-out, Latin script) transfers cleanly, while Greek does not</a:t>
-            </a:r>
-          </a:p>
-          <a:p>
-            <a:pPr/>
-            <a:r>
-              <a:rPr b="0" sz="1800"/>
-              <a:t>The bottom line is that the *source* of the English replay matters more than the exact English/EU ratio</a:t>
-            </a:r>
-          </a:p>
-        </p:txBody>
-      </p:sp>
+              <a:rPr b="0" sz="1600"/>
+              <a:t>• Cross-lingual transfer is script-dependent (Romanian transfers, Greek does not)</a:t>
+            </a:r>
+          </a:p>
+        </p:txBody>
+      </p:sp>
+      <p:pic>
+        <p:nvPicPr>
+          <p:cNvPr id="4" name="Picture 3" descr="fg_per_language_heatmap.png"/>
+          <p:cNvPicPr>
+            <a:picLocks noChangeAspect="1"/>
+          </p:cNvPicPr>
+          <p:nvPr/>
+        </p:nvPicPr>
+        <p:blipFill>
+          <a:blip r:embed="rId2"/>
+          <a:stretch>
+            <a:fillRect/>
+          </a:stretch>
+        </p:blipFill>
+        <p:spPr>
+          <a:xfrm>
+            <a:off x="6233007" y="1820245"/>
+            <a:ext cx="5501487" cy="3857590"/>
+          </a:xfrm>
+          <a:prstGeom prst="rect">
+            <a:avLst/>
+          </a:prstGeom>
+        </p:spPr>
+      </p:pic>
     </p:spTree>
   </p:cSld>
   <p:clrMapOvr>
@@ -3394,49 +3380,86 @@
           <a:lstStyle/>
           <a:p>
             <a:r>
-              <a:t>Slide 3 — Dolci-Translated SFT (the headline win)</a:t>
-            </a:r>
-          </a:p>
-        </p:txBody>
-      </p:sp>
-      <p:sp>
-        <p:nvSpPr>
-          <p:cNvPr id="3" name="Content Placeholder 2"/>
-          <p:cNvSpPr>
-            <a:spLocks noGrp="1"/>
-          </p:cNvSpPr>
-          <p:nvPr>
-            <p:ph idx="1"/>
-          </p:nvPr>
-        </p:nvSpPr>
-        <p:spPr/>
-        <p:txBody>
-          <a:bodyPr/>
+              <a:t>Slide 3 — High-quality Dolci translations (gemma-3-27b-it)</a:t>
+            </a:r>
+          </a:p>
+        </p:txBody>
+      </p:sp>
+      <p:sp>
+        <p:nvSpPr>
+          <p:cNvPr id="3" name="TextBox 2"/>
+          <p:cNvSpPr txBox="1"/>
+          <p:nvPr/>
+        </p:nvSpPr>
+        <p:spPr>
+          <a:xfrm>
+            <a:off x="457200" y="1097280"/>
+            <a:ext cx="5501487" cy="5303520"/>
+          </a:xfrm>
+          <a:prstGeom prst="rect">
+            <a:avLst/>
+          </a:prstGeom>
+          <a:noFill/>
+        </p:spPr>
+        <p:txBody>
+          <a:bodyPr wrap="square">
+            <a:spAutoFit/>
+          </a:bodyPr>
           <a:lstStyle/>
           <a:p>
             <a:pPr/>
             <a:r>
-              <a:rPr b="0" sz="1800"/>
-              <a:t>On gemma-3-27b-it translations of Dolci into 7 EU languages, two matched-compute runs show that a </a:t>
-            </a:r>
-            <a:r>
-              <a:rPr b="1" sz="1800"/>
-              <a:t>75/25 English-to-translated mix preserves English at baseline while lifting non-English Elo from 697 to 755</a:t>
-            </a:r>
-            <a:r>
-              <a:rPr b="0" sz="1800"/>
-              <a:t>, and the more aggressive 25/75 mix wins on most non-English (notably Finnish, +125 over baseline) at a ~37-point English cost</a:t>
+              <a:rPr b="0" sz="1600"/>
+              <a:t>• Switched our translated EU data from NLLB-distilled-600M to gemma-3-27b-it Dolci translations in 7 EU languages [2]</a:t>
             </a:r>
           </a:p>
           <a:p>
             <a:pPr/>
             <a:r>
-              <a:rPr b="0" sz="1800"/>
-              <a:t>Next: quality-filter the translated pool, then run the Think-SFT analogue</a:t>
-            </a:r>
-          </a:p>
-        </p:txBody>
-      </p:sp>
+              <a:rPr b="0" sz="1600"/>
+              <a:t>• Two matched-compute SFT runs at 75/25 and 25/75 English-to-translated</a:t>
+            </a:r>
+          </a:p>
+          <a:p>
+            <a:pPr/>
+            <a:r>
+              <a:rPr b="0" sz="1600"/>
+              <a:t>• Both improve non-English without sacrificing English — the headline result this round</a:t>
+            </a:r>
+          </a:p>
+          <a:p>
+            <a:pPr/>
+            <a:r>
+              <a:rPr b="0" sz="1600"/>
+              <a:t>• Next: quality-filter the translated pool, then run the Think-SFT analogue</a:t>
+            </a:r>
+          </a:p>
+        </p:txBody>
+      </p:sp>
+      <p:pic>
+        <p:nvPicPr>
+          <p:cNvPr id="4" name="Picture 3" descr="dolci_translated_per_language_elo.png"/>
+          <p:cNvPicPr>
+            <a:picLocks noChangeAspect="1"/>
+          </p:cNvPicPr>
+          <p:nvPr/>
+        </p:nvPicPr>
+        <p:blipFill>
+          <a:blip r:embed="rId2"/>
+          <a:stretch>
+            <a:fillRect/>
+          </a:stretch>
+        </p:blipFill>
+        <p:spPr>
+          <a:xfrm>
+            <a:off x="6233007" y="2387561"/>
+            <a:ext cx="5501487" cy="2722958"/>
+          </a:xfrm>
+          <a:prstGeom prst="rect">
+            <a:avLst/>
+          </a:prstGeom>
+        </p:spPr>
+      </p:pic>
     </p:spTree>
   </p:cSld>
   <p:clrMapOvr>
@@ -3471,37 +3494,51 @@
           <a:lstStyle/>
           <a:p>
             <a:r>
-              <a:t>Slide 4 — Qualitative viewer for the consortium</a:t>
-            </a:r>
-          </a:p>
-        </p:txBody>
-      </p:sp>
-      <p:sp>
-        <p:nvSpPr>
-          <p:cNvPr id="3" name="Content Placeholder 2"/>
-          <p:cNvSpPr>
-            <a:spLocks noGrp="1"/>
-          </p:cNvSpPr>
-          <p:nvPr>
-            <p:ph idx="1"/>
-          </p:nvPr>
-        </p:nvSpPr>
-        <p:spPr/>
-        <p:txBody>
-          <a:bodyPr/>
+              <a:t>Slide 4 — Qualitative completions viewer</a:t>
+            </a:r>
+          </a:p>
+        </p:txBody>
+      </p:sp>
+      <p:sp>
+        <p:nvSpPr>
+          <p:cNvPr id="3" name="TextBox 2"/>
+          <p:cNvSpPr txBox="1"/>
+          <p:nvPr/>
+        </p:nvSpPr>
+        <p:spPr>
+          <a:xfrm>
+            <a:off x="457200" y="1097280"/>
+            <a:ext cx="11277295" cy="5303520"/>
+          </a:xfrm>
+          <a:prstGeom prst="rect">
+            <a:avLst/>
+          </a:prstGeom>
+          <a:noFill/>
+        </p:spPr>
+        <p:txBody>
+          <a:bodyPr wrap="square">
+            <a:spAutoFit/>
+          </a:bodyPr>
           <a:lstStyle/>
           <a:p>
             <a:pPr/>
             <a:r>
               <a:rPr b="0" sz="1800"/>
-              <a:t>Public site at https://ferreirafabio.github.io/olmo3-multilingual-dolci-sft-progression/ shows side-by-side completions across 12 checkpoints (base, SFT baseline, and five intermediates each from the 75-en and 25-en runs), 7 EU languages, and 698 LMArena prompts stratified across 9 LMArena category tags (math, instruction-following, creativity, …)</a:t>
+              <a:t>• Public side-by-side viewer for the consortium [3]</a:t>
             </a:r>
           </a:p>
           <a:p>
             <a:pPr/>
             <a:r>
               <a:rPr b="0" sz="1800"/>
-              <a:t>A single slider scrubs training progression in lockstep across the two SFT runs, and category-filter pills plus a dark/light theme make it easy to drill into specific behaviours</a:t>
+              <a:t>• 12 checkpoints × 7 EU languages × 698 LMArena prompts</a:t>
+            </a:r>
+          </a:p>
+          <a:p>
+            <a:pPr/>
+            <a:r>
+              <a:rPr b="0" sz="1800"/>
+              <a:t>• Slider scrubs training progression in lockstep across the two SFT runs</a:t>
             </a:r>
           </a:p>
         </p:txBody>
@@ -3547,50 +3584,79 @@
       </p:sp>
       <p:sp>
         <p:nvSpPr>
-          <p:cNvPr id="3" name="Content Placeholder 2"/>
-          <p:cNvSpPr>
-            <a:spLocks noGrp="1"/>
-          </p:cNvSpPr>
-          <p:nvPr>
-            <p:ph idx="1"/>
-          </p:nvPr>
-        </p:nvSpPr>
-        <p:spPr/>
-        <p:txBody>
-          <a:bodyPr/>
+          <p:cNvPr id="3" name="TextBox 2"/>
+          <p:cNvSpPr txBox="1"/>
+          <p:nvPr/>
+        </p:nvSpPr>
+        <p:spPr>
+          <a:xfrm>
+            <a:off x="457200" y="1097280"/>
+            <a:ext cx="5501487" cy="5303520"/>
+          </a:xfrm>
+          <a:prstGeom prst="rect">
+            <a:avLst/>
+          </a:prstGeom>
+          <a:noFill/>
+        </p:spPr>
+        <p:txBody>
+          <a:bodyPr wrap="square">
+            <a:spAutoFit/>
+          </a:bodyPr>
           <a:lstStyle/>
           <a:p>
             <a:pPr/>
             <a:r>
-              <a:rPr b="0" sz="1800"/>
-              <a:t>We applied the same 75/25 SFT recipe to the </a:t>
-            </a:r>
-            <a:r>
-              <a:rPr b="1" sz="1800"/>
-              <a:t>OpenEuroLLM 9B alpha</a:t>
-            </a:r>
-            <a:r>
-              <a:rPr b="0" sz="1800"/>
-              <a:t> (`datamix-9b-80-20`, a Llama-architecture model with a Gemma tokenizer, pretrained on 4B tokens with an 80/20 English/multilingual mix), judged with Qwen3.5-27B at 500 battles per language</a:t>
+              <a:rPr b="0" sz="1600"/>
+              <a:t>• First post-training of the OpenEuroLLM 9B alpha, same 75/25 SFT recipe as the OLMo runs [4]</a:t>
             </a:r>
           </a:p>
           <a:p>
             <a:pPr/>
             <a:r>
-              <a:rPr b="0" sz="1800"/>
-              <a:t>At matched context length, Datamix-9B </a:t>
-            </a:r>
-            <a:r>
-              <a:rPr b="1" sz="1800"/>
-              <a:t>beats our OLMo 75/25 on most non-English languages</a:t>
-            </a:r>
-            <a:r>
-              <a:rPr b="0" sz="1800"/>
-              <a:t> — most strikingly on Czech, where it sets the highest non-English Elo we've measured to date — confirming that the multilingual pretraining mix carries through into post-training; English still lags, primarily because of the alpha's 2048-token context limit</a:t>
-            </a:r>
-          </a:p>
-        </p:txBody>
-      </p:sp>
+              <a:rPr b="0" sz="1600"/>
+              <a:t>• At matched context length, beats our OLMo SFT on most non-English languages</a:t>
+            </a:r>
+          </a:p>
+          <a:p>
+            <a:pPr/>
+            <a:r>
+              <a:rPr b="0" sz="1600"/>
+              <a:t>• Multilingual pretraining mix carries through into post-training</a:t>
+            </a:r>
+          </a:p>
+          <a:p>
+            <a:pPr/>
+            <a:r>
+              <a:rPr b="0" sz="1600"/>
+              <a:t>• English still lags, primarily due to the alpha's 2048-token context limit</a:t>
+            </a:r>
+          </a:p>
+        </p:txBody>
+      </p:sp>
+      <p:pic>
+        <p:nvPicPr>
+          <p:cNvPr id="4" name="Picture 3" descr="datamix_9b_per_language_elo_truncated.png"/>
+          <p:cNvPicPr>
+            <a:picLocks noChangeAspect="1"/>
+          </p:cNvPicPr>
+          <p:nvPr/>
+        </p:nvPicPr>
+        <p:blipFill>
+          <a:blip r:embed="rId2"/>
+          <a:stretch>
+            <a:fillRect/>
+          </a:stretch>
+        </p:blipFill>
+        <p:spPr>
+          <a:xfrm>
+            <a:off x="6233007" y="2387561"/>
+            <a:ext cx="5501487" cy="2722958"/>
+          </a:xfrm>
+          <a:prstGeom prst="rect">
+            <a:avLst/>
+          </a:prstGeom>
+        </p:spPr>
+      </p:pic>
     </p:spTree>
   </p:cSld>
   <p:clrMapOvr>
@@ -3625,90 +3691,155 @@
           <a:lstStyle/>
           <a:p>
             <a:r>
-              <a:t>Slide 6 — JudgeArena (NeurIPS)</a:t>
-            </a:r>
-          </a:p>
-        </p:txBody>
-      </p:sp>
-      <p:sp>
-        <p:nvSpPr>
-          <p:cNvPr id="3" name="Content Placeholder 2"/>
-          <p:cNvSpPr>
-            <a:spLocks noGrp="1"/>
-          </p:cNvSpPr>
-          <p:nvPr>
-            <p:ph idx="1"/>
-          </p:nvPr>
-        </p:nvSpPr>
-        <p:spPr/>
-        <p:txBody>
-          <a:bodyPr/>
+              <a:t>Slide 6 — JudgeArena (NeurIPS submission)</a:t>
+            </a:r>
+          </a:p>
+        </p:txBody>
+      </p:sp>
+      <p:sp>
+        <p:nvSpPr>
+          <p:cNvPr id="3" name="TextBox 2"/>
+          <p:cNvSpPr txBox="1"/>
+          <p:nvPr/>
+        </p:nvSpPr>
+        <p:spPr>
+          <a:xfrm>
+            <a:off x="457200" y="1097280"/>
+            <a:ext cx="11277295" cy="5303520"/>
+          </a:xfrm>
+          <a:prstGeom prst="rect">
+            <a:avLst/>
+          </a:prstGeom>
+          <a:noFill/>
+        </p:spPr>
+        <p:txBody>
+          <a:bodyPr wrap="square">
+            <a:spAutoFit/>
+          </a:bodyPr>
           <a:lstStyle/>
           <a:p>
             <a:pPr/>
             <a:r>
               <a:rPr b="0" sz="1800"/>
-              <a:t>JudgeArena is our open-source framework for LLM-as-a-judge evaluation; it now unifies AlpacaEval, Arena-Hard v0.1/v2.0, MT-Bench, and </a:t>
-            </a:r>
-            <a:r>
-              <a:rPr b="1" sz="1800"/>
-              <a:t>m-Arena-Hard v0.1/v2.0</a:t>
-            </a:r>
+              <a:t>• Open-source unified framework for LLM-judge evaluation [5]</a:t>
+            </a:r>
+          </a:p>
+          <a:p>
+            <a:pPr/>
             <a:r>
               <a:rPr b="0" sz="1800"/>
-              <a:t> (23 languages) behind a single interface, with any vLLM / llama.cpp / OpenRouter model usable as either contestant or judge and full reproducibility metadata logged for every run</a:t>
+              <a:t>• Now covers AlpacaEval, Arena-Hard v0.1/v2.0, MT-Bench, m-Arena-Hard v0.1/v2.0 (23 languages)</a:t>
             </a:r>
           </a:p>
           <a:p>
             <a:pPr/>
             <a:r>
               <a:rPr b="0" sz="1800"/>
-              <a:t>Our </a:t>
-            </a:r>
-            <a:r>
-              <a:rPr b="1" sz="1800"/>
-              <a:t>tuned open-weight judges</a:t>
-            </a:r>
+              <a:t>• Tuned open-weight judges match closed-model judges in meta-evaluations</a:t>
+            </a:r>
+          </a:p>
+          <a:p>
+            <a:pPr/>
             <a:r>
               <a:rPr b="0" sz="1800"/>
-              <a:t> match closed-model judges in meta-evaluations against human-preference data, both in English and multilingual settings, removing the need to depend on proprietary judges for headline numbers</a:t>
-            </a:r>
-          </a:p>
+              <a:t>• New: simulated LMArena Elo from existing human annotations; fluency-completion mode for base models</a:t>
+            </a:r>
+          </a:p>
+        </p:txBody>
+      </p:sp>
+    </p:spTree>
+  </p:cSld>
+  <p:clrMapOvr>
+    <a:masterClrMapping/>
+  </p:clrMapOvr>
+</p:sld>
+</file>
+
+<file path=ppt/slides/slide8.xml><?xml version="1.0" encoding="utf-8"?>
+<p:sld xmlns:a="http://schemas.openxmlformats.org/drawingml/2006/main" xmlns:p="http://schemas.openxmlformats.org/presentationml/2006/main" xmlns:r="http://schemas.openxmlformats.org/officeDocument/2006/relationships">
+  <p:cSld>
+    <p:spTree>
+      <p:nvGrpSpPr>
+        <p:cNvPr id="1" name=""/>
+        <p:cNvGrpSpPr/>
+        <p:nvPr/>
+      </p:nvGrpSpPr>
+      <p:grpSpPr/>
+      <p:sp>
+        <p:nvSpPr>
+          <p:cNvPr id="2" name="Title 1"/>
+          <p:cNvSpPr>
+            <a:spLocks noGrp="1"/>
+          </p:cNvSpPr>
+          <p:nvPr>
+            <p:ph type="title"/>
+          </p:nvPr>
+        </p:nvSpPr>
+        <p:spPr/>
+        <p:txBody>
+          <a:bodyPr/>
+          <a:lstStyle/>
+          <a:p>
+            <a:r>
+              <a:t>References</a:t>
+            </a:r>
+          </a:p>
+        </p:txBody>
+      </p:sp>
+      <p:sp>
+        <p:nvSpPr>
+          <p:cNvPr id="3" name="TextBox 2"/>
+          <p:cNvSpPr txBox="1"/>
+          <p:nvPr/>
+        </p:nvSpPr>
+        <p:spPr>
+          <a:xfrm>
+            <a:off x="457200" y="1097280"/>
+            <a:ext cx="11277295" cy="5303520"/>
+          </a:xfrm>
+          <a:prstGeom prst="rect">
+            <a:avLst/>
+          </a:prstGeom>
+          <a:noFill/>
+        </p:spPr>
+        <p:txBody>
+          <a:bodyPr wrap="square">
+            <a:spAutoFit/>
+          </a:bodyPr>
+          <a:lstStyle/>
           <a:p>
             <a:pPr/>
             <a:r>
               <a:rPr b="0" sz="1800"/>
-              <a:t>A new </a:t>
-            </a:r>
-            <a:r>
-              <a:rPr b="1" sz="1800"/>
-              <a:t>simulated LMArena Elo</a:t>
-            </a:r>
+              <a:t>• [1] multilingual_eu results: https://github.com/ferreirafabio/open-instruct/blob/main/oellm/experiments/multilingual_eu/results/multilingual_eu_results.md</a:t>
+            </a:r>
+          </a:p>
+          <a:p>
+            <a:pPr/>
             <a:r>
               <a:rPr b="0" sz="1800"/>
-              <a:t> mode combines existing human annotations with an LLM-judge evaluation of a target model and reproduces actual LMArena Elo to within a small per-model error (leave-one-out over 20 models), giving us a low-cost stand-in for full human arena evaluation</a:t>
+              <a:t>• [2] dolci_translated results: https://github.com/ferreirafabio/open-instruct/blob/main/oellm/experiments/multilingual_eu/results/dolci_translated_results.md</a:t>
             </a:r>
           </a:p>
           <a:p>
             <a:pPr/>
             <a:r>
               <a:rPr b="0" sz="1800"/>
-              <a:t>A </a:t>
-            </a:r>
-            <a:r>
-              <a:rPr b="1" sz="1800"/>
-              <a:t>fluency-completion</a:t>
-            </a:r>
+              <a:t>• [3] Qualitative viewer: https://ferreirafabio.github.io/olmo3-multilingual-dolci-sft-progression/</a:t>
+            </a:r>
+          </a:p>
+          <a:p>
+            <a:pPr/>
             <a:r>
               <a:rPr b="0" sz="1800"/>
-              <a:t> mode now lets us evaluate *base* models (no chat template required) in Finnish, French, German, Spanish and Swedish — useful for the EuroLLM pretrained checkpoints</a:t>
+              <a:t>• [4] datamix_9b results: https://github.com/ferreirafabio/open-instruct/blob/main/oellm/experiments/multilingual_eu/results/datamix_9b_sft_results.md</a:t>
             </a:r>
           </a:p>
           <a:p>
             <a:pPr/>
             <a:r>
               <a:rPr b="0" sz="1800"/>
-              <a:t>All the numbers in this update were produced through this pipeline</a:t>
+              <a:t>• [5] OpenJury / JudgeArena: https://github.com/OpenEuroLLM/OpenJury</a:t>
             </a:r>
           </a:p>
         </p:txBody>

</xml_diff>

<commit_message>
Tighten 2026-04-28 deck and add template-merge helper
- Slides 2-6 trimmed to 2-3 bullets each, chart-of-the-slide carries data
- Slide 2 (heatmap) gains explicit "what it shows / takeaway" framing
- Slide 4 (qualitative viewer) explains what the site does, not just stats
- Slide 5 (datamix-9b) leads with "strong SFT basis without ctx extension yet"
- All em/en dashes replaced with colons / commas / periods
- Add merge_into_deck.py: append our slides into an existing FBK template
  pptx (BLANK layout, sized to template dims, hyperlinks for refs)

Co-Authored-By: Claude Opus 4.7 <noreply@anthropic.com>
</commit_message>
<xml_diff>
--- a/oellm/meetings/llms4eu_wp4/2026-04-28.pptx
+++ b/oellm/meetings/llms4eu_wp4/2026-04-28.pptx
@@ -3111,7 +3111,7 @@
           <a:lstStyle/>
           <a:p>
             <a:r>
-              <a:t>LLMs4EU WP4 — 2026-04-28</a:t>
+              <a:t>LLMs4EU WP4: 2026-04-28</a:t>
             </a:r>
           </a:p>
         </p:txBody>
@@ -3176,7 +3176,7 @@
           <a:lstStyle/>
           <a:p>
             <a:r>
-              <a:t>Slide 1 — Recap</a:t>
+              <a:t>Slide 1: Recap</a:t>
             </a:r>
           </a:p>
         </p:txBody>
@@ -3266,7 +3266,7 @@
           <a:lstStyle/>
           <a:p>
             <a:r>
-              <a:t>Slide 2 — Multilingual SFT: language-ratio sweep</a:t>
+              <a:t>Slide 2: Multilingual SFT, language-ratio sweep</a:t>
             </a:r>
           </a:p>
         </p:txBody>
@@ -3296,28 +3296,14 @@
             <a:pPr/>
             <a:r>
               <a:rPr b="0" sz="1600"/>
-              <a:t>• Continued SFT on different English / EU language ratios [1]</a:t>
+              <a:t>• Heatmap: rows = SFT variants, columns = 12 eval languages, greener = higher Elo [1]</a:t>
             </a:r>
           </a:p>
           <a:p>
             <a:pPr/>
             <a:r>
               <a:rPr b="0" sz="1600"/>
-              <a:t>• Replaying the base SFT's own English data prevents English forgetting</a:t>
-            </a:r>
-          </a:p>
-          <a:p>
-            <a:pPr/>
-            <a:r>
-              <a:rPr b="0" sz="1600"/>
-              <a:t>• Sweet spot is around 75% English / 25% EU</a:t>
-            </a:r>
-          </a:p>
-          <a:p>
-            <a:pPr/>
-            <a:r>
-              <a:rPr b="0" sz="1600"/>
-              <a:t>• Cross-lingual transfer is script-dependent (Romanian transfers, Greek does not)</a:t>
+              <a:t>• Takeaway: only Dolci-replay variants (D/E) keep English green without giving up EU; sweet spot ≈ 75/25</a:t>
             </a:r>
           </a:p>
         </p:txBody>
@@ -3380,7 +3366,7 @@
           <a:lstStyle/>
           <a:p>
             <a:r>
-              <a:t>Slide 3 — High-quality Dolci translations (gemma-3-27b-it)</a:t>
+              <a:t>Slide 3: High-quality Dolci translations (gemma-3-27b-it)</a:t>
             </a:r>
           </a:p>
         </p:txBody>
@@ -3410,28 +3396,21 @@
             <a:pPr/>
             <a:r>
               <a:rPr b="0" sz="1600"/>
-              <a:t>• Switched our translated EU data from NLLB-distilled-600M to gemma-3-27b-it Dolci translations in 7 EU languages [2]</a:t>
+              <a:t>• gemma-3-27b-it translations of Dolci-Instruct-SFT in 7 EU languages, replacing NLLB-600M [2]</a:t>
             </a:r>
           </a:p>
           <a:p>
             <a:pPr/>
             <a:r>
               <a:rPr b="0" sz="1600"/>
-              <a:t>• Two matched-compute SFT runs at 75/25 and 25/75 English-to-translated</a:t>
+              <a:t>• Drops the Tracks A-F mixture (WildChat / lmsys / oasst2 / fusion-synth) to isolate translation quality</a:t>
             </a:r>
           </a:p>
           <a:p>
             <a:pPr/>
             <a:r>
               <a:rPr b="0" sz="1600"/>
-              <a:t>• Both improve non-English without sacrificing English — the headline result this round</a:t>
-            </a:r>
-          </a:p>
-          <a:p>
-            <a:pPr/>
-            <a:r>
-              <a:rPr b="0" sz="1600"/>
-              <a:t>• Next: quality-filter the translated pool, then run the Think-SFT analogue</a:t>
+              <a:t>• Both 75/25 and 25/75 runs improve non-English without sacrificing English (headline result)</a:t>
             </a:r>
           </a:p>
         </p:txBody>
@@ -3494,7 +3473,7 @@
           <a:lstStyle/>
           <a:p>
             <a:r>
-              <a:t>Slide 4 — Qualitative completions viewer</a:t>
+              <a:t>Slide 4: Qualitative completions viewer</a:t>
             </a:r>
           </a:p>
         </p:txBody>
@@ -3524,21 +3503,29 @@
             <a:pPr/>
             <a:r>
               <a:rPr b="0" sz="1800"/>
-              <a:t>• Public side-by-side viewer for the consortium [3]</a:t>
+              <a:t>• Public web tool that </a:t>
+            </a:r>
+            <a:r>
+              <a:rPr b="1" sz="1800"/>
+              <a:t>qualitatively compares model outputs</a:t>
+            </a:r>
+            <a:r>
+              <a:rPr b="0" sz="1800"/>
+              <a:t> side-by-side across SFT progress, dataset mixtures (75/25 vs 25/75), and the pre-SFT base, all on the same prompt</a:t>
             </a:r>
           </a:p>
           <a:p>
             <a:pPr/>
             <a:r>
               <a:rPr b="0" sz="1800"/>
-              <a:t>• 12 checkpoints × 7 EU languages × 698 LMArena prompts</a:t>
+              <a:t>• 12 checkpoints × 7 EU languages × 698 LMArena prompts; slider scrubs training in lockstep</a:t>
             </a:r>
           </a:p>
           <a:p>
             <a:pPr/>
             <a:r>
               <a:rPr b="0" sz="1800"/>
-              <a:t>• Slider scrubs training progression in lockstep across the two SFT runs</a:t>
+              <a:t>• Open the viewer [3]</a:t>
             </a:r>
           </a:p>
         </p:txBody>
@@ -3577,7 +3564,7 @@
           <a:lstStyle/>
           <a:p>
             <a:r>
-              <a:t>Slide 5 — Datamix-9B Instruct SFT (OpenEuroLLM 9B alpha)</a:t>
+              <a:t>Slide 5: Datamix-9B Instruct SFT (OpenEuroLLM 9B alpha)</a:t>
             </a:r>
           </a:p>
         </p:txBody>
@@ -3607,28 +3594,37 @@
             <a:pPr/>
             <a:r>
               <a:rPr b="0" sz="1600"/>
-              <a:t>• First post-training of the OpenEuroLLM 9B alpha, same 75/25 SFT recipe as the OLMo runs [4]</a:t>
+              <a:t>• First post-training of the OpenEuroLLM 9B alpha, same 75/25 SFT recipe as our OLMo runs [4]</a:t>
             </a:r>
           </a:p>
           <a:p>
             <a:pPr/>
             <a:r>
               <a:rPr b="0" sz="1600"/>
-              <a:t>• At matched context length, beats our OLMo SFT on most non-English languages</a:t>
+              <a:t>• </a:t>
+            </a:r>
+            <a:r>
+              <a:rPr b="1" sz="1600"/>
+              <a:t>Takeaway:</a:t>
+            </a:r>
+            <a:r>
+              <a:rPr b="0" sz="1600"/>
+              <a:t> already a very strong SFT basis. Beats our OLMo SFT on most non-English at matched context, </a:t>
+            </a:r>
+            <a:r>
+              <a:rPr b="1" sz="1600"/>
+              <a:t>without any context-length extension yet</a:t>
+            </a:r>
+            <a:r>
+              <a:rPr b="0" sz="1600"/>
+              <a:t>. Very promising for what comes after extension</a:t>
             </a:r>
           </a:p>
           <a:p>
             <a:pPr/>
             <a:r>
               <a:rPr b="0" sz="1600"/>
-              <a:t>• Multilingual pretraining mix carries through into post-training</a:t>
-            </a:r>
-          </a:p>
-          <a:p>
-            <a:pPr/>
-            <a:r>
-              <a:rPr b="0" sz="1600"/>
-              <a:t>• English still lags, primarily due to the alpha's 2048-token context limit</a:t>
+              <a:t>• English still lags due to the alpha's 2048-token context limit</a:t>
             </a:r>
           </a:p>
         </p:txBody>
@@ -3691,7 +3687,7 @@
           <a:lstStyle/>
           <a:p>
             <a:r>
-              <a:t>Slide 6 — JudgeArena (NeurIPS submission)</a:t>
+              <a:t>Slide 6: JudgeArena (NeurIPS submission)</a:t>
             </a:r>
           </a:p>
         </p:txBody>
@@ -3721,28 +3717,21 @@
             <a:pPr/>
             <a:r>
               <a:rPr b="0" sz="1800"/>
-              <a:t>• Open-source unified framework for LLM-judge evaluation [5]</a:t>
+              <a:t>• Open-source unified LLM-judge framework [5], covering AlpacaEval, Arena-Hard v0.1/v2.0, MT-Bench, m-Arena-Hard v0.1/v2.0 (23 langs)</a:t>
             </a:r>
           </a:p>
           <a:p>
             <a:pPr/>
             <a:r>
               <a:rPr b="0" sz="1800"/>
-              <a:t>• Now covers AlpacaEval, Arena-Hard v0.1/v2.0, MT-Bench, m-Arena-Hard v0.1/v2.0 (23 languages)</a:t>
+              <a:t>• Tuned open-weight judges match closed-model judges in meta-eval</a:t>
             </a:r>
           </a:p>
           <a:p>
             <a:pPr/>
             <a:r>
               <a:rPr b="0" sz="1800"/>
-              <a:t>• Tuned open-weight judges match closed-model judges in meta-evaluations</a:t>
-            </a:r>
-          </a:p>
-          <a:p>
-            <a:pPr/>
-            <a:r>
-              <a:rPr b="0" sz="1800"/>
-              <a:t>• New: simulated LMArena Elo from existing human annotations; fluency-completion mode for base models</a:t>
+              <a:t>• New: simulated LMArena Elo from human annotations + fluency mode for base models</a:t>
             </a:r>
           </a:p>
         </p:txBody>

</xml_diff>